<commit_message>
Trabajo 1: alinea el objetivo general de la presentación con el documento
Co-Authored-By: Claude Sonnet 5.5 <noreply@anthropic.com>
Claude-Session: https://claude.ai/code/session_016S2e3FucHCtgupXcPL28A1
</commit_message>
<xml_diff>
--- a/Proyecto de Investigación 1/Trabajo 1/Presentacion-Kuhn-y-seguridad-informatica.pptx
+++ b/Proyecto de Investigación 1/Trabajo 1/Presentacion-Kuhn-y-seguridad-informatica.pptx
@@ -122,12 +122,12 @@
   <p:extLst>
     <p:ext uri="{521415D9-36F7-43E2-AB2F-B90AF26B5E84}">
       <p14:sectionLst xmlns:p14="http://schemas.microsoft.com/office/powerpoint/2010/main">
-        <p14:section name="Apertura" id="{acfa8abe-0c4e-8b25-df1a-45625a3821a0}">
+        <p14:section name="Apertura" id="{1eb9b74f-c96d-ee4c-cd89-f07193a3d113}">
           <p14:sldIdLst>
             <p14:sldId id="256"/>
           </p14:sldIdLst>
         </p14:section>
-        <p14:section name="Teoría" id="{fc69a40a-bf8c-de8d-e391-6277edae6ec1}">
+        <p14:section name="Teoría" id="{2ed6e2b6-a877-c392-3187-cb531a1a0191}">
           <p14:sldIdLst>
             <p14:sldId id="257"/>
             <p14:sldId id="258"/>
@@ -136,13 +136,13 @@
             <p14:sldId id="261"/>
           </p14:sldIdLst>
         </p14:section>
-        <p14:section name="Aplicación" id="{c2fd57dd-b768-ac1c-9fbe-d9d686ff9e51}">
+        <p14:section name="Aplicación" id="{4d0327b5-09b0-e595-571e-1388e637e4f6}">
           <p14:sldIdLst>
             <p14:sldId id="262"/>
             <p14:sldId id="263"/>
           </p14:sldIdLst>
         </p14:section>
-        <p14:section name="Problema" id="{e9ef2151-d93b-2474-40b4-fa38d8d9166f}">
+        <p14:section name="Problema" id="{edc1c368-72c3-8d5e-a256-65adfe288484}">
           <p14:sldIdLst>
             <p14:sldId id="264"/>
             <p14:sldId id="265"/>
@@ -152,7 +152,7 @@
             <p14:sldId id="269"/>
           </p14:sldIdLst>
         </p14:section>
-        <p14:section name="Cierre" id="{1773fc40-3432-d3dc-6b1c-f84aaf4e62c9}">
+        <p14:section name="Cierre" id="{405dcd5f-92dd-80c3-1584-d0b4f0f60883}">
           <p14:sldIdLst>
             <p14:sldId id="270"/>
             <p14:sldId id="271"/>
@@ -3823,7 +3823,7 @@
                 <a:ea typeface="Calibri" pitchFamily="34" charset="-122"/>
                 <a:cs typeface="Calibri" pitchFamily="34" charset="-120"/>
               </a:rPr>
-              <a:t>Analizar los factores organizacionales que influyen en la adopción de prácticas de seguridad durante el ciclo de desarrollo de software en equipos de empresas medianas del área metropolitana de Guatemala en 2027.</a:t>
+              <a:t>Analizar los factores organizacionales que inciden en la adopción de prácticas de seguridad durante el ciclo de desarrollo de software en equipos de desarrollo de empresas medianas del área metropolitana de Guatemala en el año 2027.</a:t>
             </a:r>
             <a:endParaRPr lang="en-US" sz="1600" dirty="0"/>
           </a:p>

</xml_diff>